<commit_message>
docs & eval: final PlayHack consistency patch, official evaluator, updated deck and readme
</commit_message>
<xml_diff>
--- a/Athlete_Injury_Prediction_Competition.pptx
+++ b/Athlete_Injury_Prediction_Competition.pptx
@@ -3285,7 +3285,7 @@
             </a:r>
             <a:br/>
             <a:r>
-              <a:t>Zero Temporal Leakage • Fold-Local Preprocessing • Multi-Target Ensemble</a:t>
+              <a:t>Strict Temporal Firewall • Fold-Local Preprocessing • Multi-Target Ensemble</a:t>
             </a:r>
           </a:p>
         </p:txBody>
@@ -3511,7 +3511,7 @@
               </a:defRPr>
             </a:pPr>
             <a:r>
-              <a:t>Injury Risk Classification</a:t>
+              <a:t>Task A: Injury Risk</a:t>
             </a:r>
           </a:p>
         </p:txBody>
@@ -3552,7 +3552,7 @@
           <a:p>
             <a:pPr>
               <a:spcBef>
-                <a:spcPts val="800"/>
+                <a:spcPts val="600"/>
               </a:spcBef>
               <a:defRPr sz="1200">
                 <a:solidFill>
@@ -3569,13 +3569,17 @@
             </a:r>
             <a:br/>
             <a:r>
+              <a:t>Precision: 97.23% | Recall: 50.19%</a:t>
+            </a:r>
+            <a:br/>
+            <a:r>
               <a:t>Brier Score: 0.1453 | Accuracy: 82.1%</a:t>
             </a:r>
           </a:p>
           <a:p>
             <a:pPr>
               <a:spcBef>
-                <a:spcPts val="1600"/>
+                <a:spcPts val="1400"/>
               </a:spcBef>
               <a:defRPr sz="1150">
                 <a:solidFill>
@@ -3668,7 +3672,7 @@
               </a:defRPr>
             </a:pPr>
             <a:r>
-              <a:t>Onset Day Offset</a:t>
+              <a:t>Task B: Onset Timing</a:t>
             </a:r>
           </a:p>
         </p:txBody>
@@ -3709,7 +3713,7 @@
           <a:p>
             <a:pPr>
               <a:spcBef>
-                <a:spcPts val="800"/>
+                <a:spcPts val="600"/>
               </a:spcBef>
               <a:defRPr sz="1200">
                 <a:solidFill>
@@ -3718,25 +3722,25 @@
               </a:defRPr>
             </a:pPr>
             <a:r>
-              <a:t>Mean Absolute Error (Fold: 2.65 ± 0.11d)</a:t>
-            </a:r>
-            <a:br/>
-            <a:r>
-              <a:t>RMSE: 4.0984 days</a:t>
-            </a:r>
-            <a:br/>
-            <a:r>
-              <a:t>R² Score: 0.7820 (78.2% variance explained)</a:t>
-            </a:r>
-            <a:br/>
-            <a:r>
-              <a:t>*Conditional on Actual Injury (N=1,050)</a:t>
+              <a:t>Conditional MAE (Detected Injured): 2.64d</a:t>
+            </a:r>
+            <a:br/>
+            <a:r>
+              <a:t>RMSE: 4.0984d | R² Score: 0.7820</a:t>
+            </a:r>
+            <a:br/>
+            <a:r>
+              <a:t>Penalized MAE (n_risk=30): 15.31d</a:t>
+            </a:r>
+            <a:br/>
+            <a:r>
+              <a:t>Onset Skill Score: +0.4897</a:t>
             </a:r>
           </a:p>
           <a:p>
             <a:pPr>
               <a:spcBef>
-                <a:spcPts val="1600"/>
+                <a:spcPts val="1400"/>
               </a:spcBef>
               <a:defRPr sz="1150">
                 <a:solidFill>
@@ -3829,7 +3833,7 @@
               </a:defRPr>
             </a:pPr>
             <a:r>
-              <a:t>Recovery Duration</a:t>
+              <a:t>Task B: Recovery Duration</a:t>
             </a:r>
           </a:p>
         </p:txBody>
@@ -3870,7 +3874,7 @@
           <a:p>
             <a:pPr>
               <a:spcBef>
-                <a:spcPts val="800"/>
+                <a:spcPts val="600"/>
               </a:spcBef>
               <a:defRPr sz="1200">
                 <a:solidFill>
@@ -3879,25 +3883,25 @@
               </a:defRPr>
             </a:pPr>
             <a:r>
-              <a:t>Mean Absolute Error (Fold: 2.96 ± 0.08d)</a:t>
-            </a:r>
-            <a:br/>
-            <a:r>
-              <a:t>RMSE: 3.4700 days</a:t>
-            </a:r>
-            <a:br/>
-            <a:r>
-              <a:t>R² Score: 0.2037</a:t>
-            </a:r>
-            <a:br/>
-            <a:r>
-              <a:t>*Conditional on Actual Injury (N=1,050)</a:t>
+              <a:t>Conditional MAE (Detected Injured): 2.96d</a:t>
+            </a:r>
+            <a:br/>
+            <a:r>
+              <a:t>RMSE: 3.4700d | R² Score: 0.2037</a:t>
+            </a:r>
+            <a:br/>
+            <a:r>
+              <a:t>Penalized MAE (n_risk=30): 16.42d</a:t>
+            </a:r>
+            <a:br/>
+            <a:r>
+              <a:t>Recovery Skill Score: +0.4527</a:t>
             </a:r>
           </a:p>
           <a:p>
             <a:pPr>
               <a:spcBef>
-                <a:spcPts val="1600"/>
+                <a:spcPts val="1400"/>
               </a:spcBef>
               <a:defRPr sz="1150">
                 <a:solidFill>
@@ -3910,7 +3914,7 @@
             </a:r>
             <a:br/>
             <a:r>
-              <a:t>Pre-injury wearables capture 20.4% variance; regularized Bayesian shrinkage bounds MSE on residual noise.</a:t>
+              <a:t>Pre-injury wearables capture 20.4% variance; regularized shrinkage bounds error on residual noise.</a:t>
             </a:r>
           </a:p>
         </p:txBody>
@@ -4365,11 +4369,11 @@
               </a:defRPr>
             </a:pPr>
             <a:r>
-              <a:t>1. Leakage-Free Temporal Architecture:</a:t>
-            </a:r>
-            <a:br/>
-            <a:r>
-              <a:t>   Strict cutoff (Date &lt;= 2026-02-03) verified across all 5 streams.</a:t>
+              <a:t>1. Strict Temporal Firewall:</a:t>
+            </a:r>
+            <a:br/>
+            <a:r>
+              <a:t>   Cutoff (Date &lt;= 2026-02-03) strictly enforced across all 5 streams.</a:t>
             </a:r>
             <a:br/>
             <a:br/>
@@ -4523,7 +4527,11 @@
             </a:r>
             <a:br/>
             <a:r>
-              <a:t>  ✓ Gating Invariant: 845 healthy athletes strictly 0 offset/duration</a:t>
+              <a:t>  ✓ Complete timing predictions populated across all 1,100 rows</a:t>
+            </a:r>
+            <a:br/>
+            <a:r>
+              <a:t>  ✓ 255 predicted injured (23.2%), 845 non-injured (76.8%)</a:t>
             </a:r>
             <a:br/>
             <a:br/>
@@ -4695,7 +4703,7 @@
               </a:defRPr>
             </a:pPr>
             <a:r>
-              <a:t>Forecasting future 30-day injury probability, conditional onset timing, and recovery duration.</a:t>
+              <a:t>Forecasting future 30-day injury probability, onset timing, and recovery duration across all athletes.</a:t>
             </a:r>
           </a:p>
         </p:txBody>
@@ -4803,14 +4811,14 @@
           <a:lstStyle/>
           <a:p>
             <a:pPr>
-              <a:defRPr sz="1250">
+              <a:defRPr sz="1200">
                 <a:solidFill>
                   <a:srgbClr val="F8FAFC"/>
                 </a:solidFill>
               </a:defRPr>
             </a:pPr>
             <a:r>
-              <a:t>• Core Research Question:</a:t>
+              <a:t>• Core Predictive Question:</a:t>
             </a:r>
             <a:br/>
             <a:r>
@@ -4828,19 +4836,19 @@
             <a:br/>
             <a:br/>
             <a:r>
-              <a:t>• The 3 Hierarchical Questions:</a:t>
-            </a:r>
-            <a:br/>
-            <a:r>
-              <a:t>  1. Injury Occurrence: Will the athlete sustain an injury?</a:t>
-            </a:r>
-            <a:br/>
-            <a:r>
-              <a:t>  2. Onset Timing: If injured, on which day (1–30) will onset occur?</a:t>
-            </a:r>
-            <a:br/>
-            <a:r>
-              <a:t>  3. Recovery Duration: If injured, how many days (5–20) will rehab take?</a:t>
+              <a:t>• The Official PlayHack Tasks:</a:t>
+            </a:r>
+            <a:br/>
+            <a:r>
+              <a:t>  1. Task A: Will an injury occur in the risk window? (Evaluated via F1-score)</a:t>
+            </a:r>
+            <a:br/>
+            <a:r>
+              <a:t>  2. Task B: Onset Timing &amp; Recovery Duration (Evaluated for actually injured athletes)</a:t>
+            </a:r>
+            <a:br/>
+            <a:r>
+              <a:t>  3. Missed-Injury Penalty: n_risk = 30 applied to both timing targets on false negatives.</a:t>
             </a:r>
           </a:p>
         </p:txBody>
@@ -4948,7 +4956,7 @@
           <a:lstStyle/>
           <a:p>
             <a:pPr>
-              <a:defRPr sz="1250">
+              <a:defRPr sz="1200">
                 <a:solidFill>
                   <a:srgbClr val="F8FAFC"/>
                 </a:solidFill>
@@ -4968,7 +4976,7 @@
             <a:br/>
             <a:br/>
             <a:r>
-              <a:t>2. onset_day_offset (Conditional Timing Regression)</a:t>
+              <a:t>2. onset_day_offset (Timing Prediction)</a:t>
             </a:r>
             <a:br/>
             <a:r>
@@ -4976,12 +4984,12 @@
             </a:r>
             <a:br/>
             <a:r>
-              <a:t>   • Defined strictly for injured athletes; gated to 0 for healthy.</a:t>
-            </a:r>
-            <a:br/>
-            <a:br/>
-            <a:r>
-              <a:t>3. recovery_duration (Conditional Duration Regression)</a:t>
+              <a:t>   • Provided for ALL athletes per official PlayHack PS requirement.</a:t>
+            </a:r>
+            <a:br/>
+            <a:br/>
+            <a:r>
+              <a:t>3. recovery_duration (Duration Prediction)</a:t>
             </a:r>
             <a:br/>
             <a:r>
@@ -4989,7 +4997,7 @@
             </a:r>
             <a:br/>
             <a:r>
-              <a:t>   • Defined strictly for injured athletes; gated to 0 for healthy.</a:t>
+              <a:t>   • Provided for ALL athletes per official PlayHack PS requirement.</a:t>
             </a:r>
           </a:p>
         </p:txBody>
@@ -5863,15 +5871,15 @@
               </a:defRPr>
             </a:pPr>
             <a:r>
-              <a:t>1. Balanced Target Topology:</a:t>
-            </a:r>
-            <a:br/>
-            <a:r>
-              <a:t>   • 35% injury baseline (1,050 / 3,000).</a:t>
-            </a:r>
-            <a:br/>
-            <a:r>
-              <a:t>   • Onset days spread smoothly across the entire 30-day risk window.</a:t>
+              <a:t>1. 35% Positive Injury Prevalence:</a:t>
+            </a:r>
+            <a:br/>
+            <a:r>
+              <a:t>   • Exactly 1,050 of 3,000 training athletes.</a:t>
+            </a:r>
+            <a:br/>
+            <a:r>
+              <a:t>   • Onset days spread across the 30-day risk window.</a:t>
             </a:r>
             <a:br/>
             <a:r>
@@ -6178,7 +6186,7 @@
               </a:defRPr>
             </a:pPr>
             <a:r>
-              <a:t>1. Workload Spikes vs. Onset Timing (r = -0.863):</a:t>
+              <a:t>1. Workload Spikes Associated with Early Onset (r = -0.863):</a:t>
             </a:r>
             <a:br/>
             <a:r>
@@ -6186,20 +6194,20 @@
             </a:r>
             <a:br/>
             <a:r>
-              <a:t>   • Meaning: Sudden surges accelerate neuromuscular breakdown.</a:t>
-            </a:r>
-            <a:br/>
-            <a:br/>
-            <a:r>
-              <a:t>2. Sleep Deficit Multiplier:</a:t>
-            </a:r>
-            <a:br/>
-            <a:r>
-              <a:t>   • Finding: Daily sleep debt (&gt;60 mins) combined with high training load increases injury risk by 1.8x.</a:t>
-            </a:r>
-            <a:br/>
-            <a:r>
-              <a:t>   • Meaning: Inadequate rest impairs muscle tissue repair.</a:t>
+              <a:t>   • Meaning: Sudden surges provide strong predictive signal for early breakdown.</a:t>
+            </a:r>
+            <a:br/>
+            <a:br/>
+            <a:r>
+              <a:t>2. Sleep Deficit Interaction:</a:t>
+            </a:r>
+            <a:br/>
+            <a:r>
+              <a:t>   • Finding: Daily sleep debt (&gt;60 mins) combined with high training load is associated with 1.8x higher injury rate.</a:t>
+            </a:r>
+            <a:br/>
+            <a:r>
+              <a:t>   • Meaning: Inadequate rest compounds workload strain.</a:t>
             </a:r>
             <a:br/>
             <a:br/>
@@ -6208,7 +6216,7 @@
             </a:r>
             <a:br/>
             <a:r>
-              <a:t>   • Finding: % hours with HR &gt;= 120 bpm outside training is an informative marker of systemic autonomic fatigue.</a:t>
+              <a:t>   • Finding: % hours with HR &gt;= 120 bpm outside training is an informative marker of systemic fatigue.</a:t>
             </a:r>
           </a:p>
         </p:txBody>
@@ -6354,7 +6362,7 @@
               </a:defRPr>
             </a:pPr>
             <a:r>
-              <a:t>Mathematical guarantee that zero post-cutoff observations contaminate training or validation features.</a:t>
+              <a:t>Strict temporal filtering preventing post-cutoff observations from contaminating features.</a:t>
             </a:r>
           </a:p>
         </p:txBody>
@@ -6496,7 +6504,7 @@
             </a:r>
             <a:br/>
             <a:r>
-              <a:t>  Raw training files contain 60 days of data, while test contains 30 days. Unwindowed aggregation would silently leak future injury drops.</a:t>
+              <a:t>  Raw training files contain 60 days of data, while test contains 30 days. Unwindowed aggregation would silently leak future injury activity drops.</a:t>
             </a:r>
             <a:br/>
             <a:br/>
@@ -6585,7 +6593,7 @@
               </a:defRPr>
             </a:pPr>
             <a:r>
-              <a:t>Target Shuffle Sanity Defense</a:t>
+              <a:t>Leakage Sanity Evidence</a:t>
             </a:r>
           </a:p>
         </p:txBody>
@@ -6646,11 +6654,11 @@
             <a:br/>
             <a:br/>
             <a:r>
-              <a:t>• Definitive Proof:</a:t>
-            </a:r>
-            <a:br/>
-            <a:r>
-              <a:t>  Proves that predictive performance stems strictly from genuine pre-cutoff physiological signal, with ZERO structural leakage.</a:t>
+              <a:t>• Leakage Sanity Evidence:</a:t>
+            </a:r>
+            <a:br/>
+            <a:r>
+              <a:t>  Demonstrates that predictive performance stems strictly from genuine pre-cutoff physiological signal, with zero structural leakage.</a:t>
             </a:r>
           </a:p>
         </p:txBody>
@@ -7435,7 +7443,7 @@
               </a:defRPr>
             </a:pPr>
             <a:r>
-              <a:t>Hierarchical Multi-Target Modeling Architecture</a:t>
+              <a:t>Multi-Target Modeling Architecture</a:t>
             </a:r>
           </a:p>
           <a:p>
@@ -7450,7 +7458,7 @@
               </a:defRPr>
             </a:pPr>
             <a:r>
-              <a:t>Multi-model weighted probability ensemble paired with conditional regression models.</a:t>
+              <a:t>Multi-model weighted probability ensemble paired with dual bounded regressors.</a:t>
             </a:r>
           </a:p>
         </p:txBody>
@@ -7591,7 +7599,7 @@
             <a:br/>
             <a:br/>
             <a:r>
-              <a:t>• Decision Gate: Threshold 0.50 yields 96.2% precision and 82.1% accuracy.</a:t>
+              <a:t>• Decision Gate: Threshold 0.50 yields 97.23% precision and 82.1% accuracy.</a:t>
             </a:r>
           </a:p>
         </p:txBody>
@@ -7869,11 +7877,11 @@
             <a:br/>
             <a:br/>
             <a:r>
-              <a:t>• Bayesian Shrinkage Formulation:</a:t>
-            </a:r>
-            <a:br/>
-            <a:r>
-              <a:t>  Regularization prevents extreme tail variance on noisy residual signal (MAE = 2.96 days).</a:t>
+              <a:t>• Regularized Shrinkage Formulation:</a:t>
+            </a:r>
+            <a:br/>
+            <a:r>
+              <a:t>  L2 regularization prevents extreme tail variance on noisy residual signal (MAE = 2.96 days).</a:t>
             </a:r>
           </a:p>
         </p:txBody>

</xml_diff>

<commit_message>
fix: pre-submission patch - official skill score, unpenalized/penalized metrics, strict validation
</commit_message>
<xml_diff>
--- a/Athlete_Injury_Prediction_Competition.pptx
+++ b/Athlete_Injury_Prediction_Competition.pptx
@@ -3715,14 +3715,14 @@
               <a:spcBef>
                 <a:spcPts val="600"/>
               </a:spcBef>
-              <a:defRPr sz="1200">
+              <a:defRPr sz="1150">
                 <a:solidFill>
                   <a:srgbClr val="F8FAFC"/>
                 </a:solidFill>
               </a:defRPr>
             </a:pPr>
             <a:r>
-              <a:t>Conditional MAE (Detected Injured): 2.64d</a:t>
+              <a:t>Unpenalized MAE (Actually Injured): 2.64d</a:t>
             </a:r>
             <a:br/>
             <a:r>
@@ -3730,11 +3730,11 @@
             </a:r>
             <a:br/>
             <a:r>
-              <a:t>Penalized MAE (n_risk=30): 15.31d</a:t>
-            </a:r>
-            <a:br/>
-            <a:r>
-              <a:t>Onset Skill Score: +0.4897</a:t>
+              <a:t>Onset Skill vs Mean Baseline (7.61d): +0.6527</a:t>
+            </a:r>
+            <a:br/>
+            <a:r>
+              <a:t>Official Penalized MAE (n_risk=30): 15.31d*</a:t>
             </a:r>
           </a:p>
           <a:p>
@@ -3742,18 +3742,14 @@
               <a:spcBef>
                 <a:spcPts val="1400"/>
               </a:spcBef>
-              <a:defRPr sz="1150">
+              <a:defRPr sz="1050">
                 <a:solidFill>
                   <a:srgbClr val="38BDF8"/>
                 </a:solidFill>
               </a:defRPr>
             </a:pPr>
             <a:r>
-              <a:t>Key Takeaway:</a:t>
-            </a:r>
-            <a:br/>
-            <a:r>
-              <a:t>Onset day is substantially predictable within ~2.6 days due to acute workload spike dynamics.</a:t>
+              <a:t>*Note: Official penalized MAE additionally includes n_risk=30 for missed injuries (523 false negatives).</a:t>
             </a:r>
           </a:p>
         </p:txBody>
@@ -3876,14 +3872,14 @@
               <a:spcBef>
                 <a:spcPts val="600"/>
               </a:spcBef>
-              <a:defRPr sz="1200">
+              <a:defRPr sz="1150">
                 <a:solidFill>
                   <a:srgbClr val="F8FAFC"/>
                 </a:solidFill>
               </a:defRPr>
             </a:pPr>
             <a:r>
-              <a:t>Conditional MAE (Detected Injured): 2.96d</a:t>
+              <a:t>Unpenalized MAE (Actually Injured): 2.96d</a:t>
             </a:r>
             <a:br/>
             <a:r>
@@ -3891,11 +3887,11 @@
             </a:r>
             <a:br/>
             <a:r>
-              <a:t>Penalized MAE (n_risk=30): 16.42d</a:t>
-            </a:r>
-            <a:br/>
-            <a:r>
-              <a:t>Recovery Skill Score: +0.4527</a:t>
+              <a:t>Recovery Skill vs Mean Baseline (3.24d): +0.0860</a:t>
+            </a:r>
+            <a:br/>
+            <a:r>
+              <a:t>Official Penalized MAE (n_risk=30): 16.42d*</a:t>
             </a:r>
           </a:p>
           <a:p>
@@ -3903,18 +3899,14 @@
               <a:spcBef>
                 <a:spcPts val="1400"/>
               </a:spcBef>
-              <a:defRPr sz="1150">
+              <a:defRPr sz="1050">
                 <a:solidFill>
                   <a:srgbClr val="38BDF8"/>
                 </a:solidFill>
               </a:defRPr>
             </a:pPr>
             <a:r>
-              <a:t>Key Takeaway:</a:t>
-            </a:r>
-            <a:br/>
-            <a:r>
-              <a:t>Pre-injury wearables capture 20.4% variance; regularized shrinkage bounds error on residual noise.</a:t>
+              <a:t>*Note: Official penalized MAE additionally includes n_risk=30 for missed injuries (523 false negatives).</a:t>
             </a:r>
           </a:p>
         </p:txBody>
@@ -4045,7 +4037,7 @@
               </a:defRPr>
             </a:pPr>
             <a:r>
-              <a:t>Model Explainability &amp; Honest Diagnostic Analysis</a:t>
+              <a:t>Model Explainability &amp; Diagnostic Analysis</a:t>
             </a:r>
           </a:p>
           <a:p>
@@ -4396,7 +4388,7 @@
             <a:br/>
             <a:br/>
             <a:r>
-              <a:t>4. Honest Diagnostic Transparency:</a:t>
+              <a:t>4. Diagnostic Transparency:</a:t>
             </a:r>
             <a:br/>
             <a:r>
@@ -5557,7 +5549,7 @@
           <a:lstStyle/>
           <a:p>
             <a:pPr>
-              <a:defRPr sz="1150">
+              <a:defRPr sz="1100">
                 <a:solidFill>
                   <a:srgbClr val="F8FAFC"/>
                 </a:solidFill>
@@ -5568,7 +5560,7 @@
             </a:r>
             <a:br/>
             <a:r>
-              <a:t>  Kolmogorov-Smirnov tests confirm zero demographic shift between train and test (p &gt; 0.18).</a:t>
+              <a:t>  Most numeric demographic features showed no significant train-test shift; categorical drift was detected for position and dominant side.</a:t>
             </a:r>
             <a:br/>
             <a:br/>
@@ -5586,7 +5578,7 @@
             </a:r>
             <a:br/>
             <a:r>
-              <a:t>  Sparse weight logs (33% null) and duplicate non-ISO files were safely excluded.</a:t>
+              <a:t>  Weight logs were excluded due to substantial missingness and limited athlete coverage.</a:t>
             </a:r>
           </a:p>
         </p:txBody>
@@ -6186,7 +6178,7 @@
               </a:defRPr>
             </a:pPr>
             <a:r>
-              <a:t>1. Workload Spikes Associated with Early Onset (r = -0.863):</a:t>
+              <a:t>1. Workload Spikes Associated with Earlier Onset (r = -0.863):</a:t>
             </a:r>
             <a:br/>
             <a:r>
@@ -6593,7 +6585,7 @@
               </a:defRPr>
             </a:pPr>
             <a:r>
-              <a:t>Leakage Sanity Evidence</a:t>
+              <a:t>Leakage Sanity Check</a:t>
             </a:r>
           </a:p>
         </p:txBody>
@@ -6641,7 +6633,7 @@
             </a:r>
             <a:br/>
             <a:r>
-              <a:t>  - Shuffled Target ROC-AUC: 0.4952 (Collapses to exact 0.5000 random coin-flip)</a:t>
+              <a:t>  - Shuffled Target ROC-AUC: 0.4952 (Near-random ROC-AUC of 0.4952)</a:t>
             </a:r>
             <a:br/>
             <a:r>
@@ -7740,7 +7732,7 @@
             </a:r>
             <a:br/>
             <a:r>
-              <a:t>  MAE = 2.64 days, R² = 0.7820 (explains 78.2% of timing variance among injured).</a:t>
+              <a:t>  Unpenalized MAE = 2.64 days, R² = 0.7820 (explains 78.2% of timing variance among injured).</a:t>
             </a:r>
           </a:p>
         </p:txBody>
@@ -7881,7 +7873,7 @@
             </a:r>
             <a:br/>
             <a:r>
-              <a:t>  L2 regularization prevents extreme tail variance on noisy residual signal (MAE = 2.96 days).</a:t>
+              <a:t>  L2 regularization prevents extreme tail variance on noisy residual signal (Unpenalized MAE = 2.96 days).</a:t>
             </a:r>
           </a:p>
         </p:txBody>

</xml_diff>